<commit_message>
Blank out track-record section on team slide
Co-Authored-By: Claude Opus 5.5 <noreply@anthropic.com>
Claude-Session: https://claude.ai/code/session_016pBMAvASq6cN2bMHw23wwR
</commit_message>
<xml_diff>
--- a/proposals/alma_houterasu_proposal_20260930.pptx
+++ b/proposals/alma_houterasu_proposal_20260930.pptx
@@ -788,7 +788,7 @@
             <a:r>
               <a:rPr lang="en-US" dirty="0"/>
               <a:t>体制です。少人数ですが、最初から最後まで同じメンバーで担当します。途中で担当が替わって話が戻る、ということはありません。
-私たちは、医療や健康など、正確さが求められる専門分野の情報を一般の方に伝わる形にするPRを続けてきました。法律も同じで、正確さを崩さずに『自分ごと』に感じてもらう言葉づくりが肝だと考えています。
+（右側の実績欄について説明する）
 法律の内容の正確さは御センターに確認いただき、私たちは伝わり方に責任を持つ、という役割分担を想定しています。</a:t>
             </a:r>
             <a:endParaRPr lang="en-US" dirty="0"/>
@@ -5274,7 +5274,7 @@
                 <a:ea typeface="Yu Gothic" pitchFamily="34" charset="-122"/>
                 <a:cs typeface="Yu Gothic" pitchFamily="34" charset="-120"/>
               </a:rPr>
-              <a:t>テレビ・Webの制作現場の目線で、伝わり方と実現性を点検します。</a:t>
+              <a:t>伝わり方と実現性を、編集の目線で点検します。</a:t>
             </a:r>
             <a:endParaRPr lang="en-US" sz="1200" dirty="0"/>
           </a:p>
@@ -5356,6 +5356,41 @@
         <p:spPr>
           <a:xfrm>
             <a:off x="7132320" y="2240280"/>
+            <a:ext cx="4007815" cy="2514600"/>
+          </a:xfrm>
+          <a:prstGeom prst="rect">
+            <a:avLst/>
+          </a:prstGeom>
+          <a:solidFill>
+            <a:srgbClr val="FFFFFF"/>
+          </a:solidFill>
+          <a:ln w="12700">
+            <a:solidFill>
+              <a:srgbClr val="B5B5B0"/>
+            </a:solidFill>
+            <a:prstDash val="dash"/>
+          </a:ln>
+        </p:spPr>
+        <p:txBody>
+          <a:bodyPr wrap="square" lIns="1905" tIns="1905" rIns="1905" bIns="1905" rtlCol="0" anchor="t"/>
+          <a:lstStyle/>
+          <a:p>
+            <a:pPr indent="0" marL="0">
+              <a:buNone/>
+            </a:pPr>
+            <a:endParaRPr lang="en-US" sz="1250" dirty="0"/>
+          </a:p>
+        </p:txBody>
+      </p:sp>
+      <p:sp>
+        <p:nvSpPr>
+          <p:cNvPr id="20" name="Text 18"/>
+          <p:cNvSpPr txBox="1"/>
+          <p:nvPr/>
+        </p:nvSpPr>
+        <p:spPr>
+          <a:xfrm>
+            <a:off x="7132320" y="4937760"/>
             <a:ext cx="4007815" cy="822960"/>
           </a:xfrm>
           <a:prstGeom prst="rect">
@@ -5375,159 +5410,23 @@
               <a:buNone/>
             </a:pPr>
             <a:r>
-              <a:rPr lang="en-US" sz="1600" b="1" dirty="0">
-                <a:solidFill>
-                  <a:srgbClr val="1F1F1F"/>
-                </a:solidFill>
-                <a:latin typeface="Yu Mincho" pitchFamily="34" charset="0"/>
-                <a:ea typeface="Yu Mincho" pitchFamily="34" charset="-122"/>
-                <a:cs typeface="Yu Mincho" pitchFamily="34" charset="-120"/>
-              </a:rPr>
-              <a:t>専門的な情報を、一般の人に正しく伝わる形にするPRを続けてきました。</a:t>
-            </a:r>
-            <a:endParaRPr lang="en-US" sz="1600" dirty="0"/>
-          </a:p>
-        </p:txBody>
-      </p:sp>
-      <p:sp>
-        <p:nvSpPr>
-          <p:cNvPr id="20" name="Text 18"/>
-          <p:cNvSpPr txBox="1"/>
-          <p:nvPr/>
-        </p:nvSpPr>
-        <p:spPr>
-          <a:xfrm>
-            <a:off x="7132320" y="3246120"/>
-            <a:ext cx="4007815" cy="1554480"/>
-          </a:xfrm>
-          <a:prstGeom prst="rect">
-            <a:avLst/>
-          </a:prstGeom>
-          <a:noFill/>
-          <a:ln/>
-        </p:spPr>
-        <p:txBody>
-          <a:bodyPr wrap="square" lIns="0" tIns="0" rIns="0" bIns="0" rtlCol="0" anchor="t"/>
-          <a:lstStyle/>
-          <a:p>
-            <a:pPr marL="342900" indent="-342900">
-              <a:lnSpc>
-                <a:spcPct val="130000"/>
-              </a:lnSpc>
-              <a:spcAft>
-                <a:spcPts val="800"/>
-              </a:spcAft>
-              <a:buSzPct val="100000"/>
-              <a:buChar char="•"/>
-            </a:pPr>
-            <a:r>
-              <a:rPr lang="en-US" sz="1250" dirty="0">
-                <a:solidFill>
-                  <a:srgbClr val="1F1F1F"/>
-                </a:solidFill>
-                <a:latin typeface="Yu Gothic" pitchFamily="34" charset="0"/>
-                <a:ea typeface="Yu Gothic" pitchFamily="34" charset="-122"/>
-                <a:cs typeface="Yu Gothic" pitchFamily="34" charset="-120"/>
-              </a:rPr>
-              <a:t>医療・健康など、正確さが求められる分野のPR経験</a:t>
-            </a:r>
-            <a:endParaRPr lang="en-US" sz="1250" dirty="0"/>
-          </a:p>
-          <a:p>
-            <a:pPr marL="342900" indent="-342900">
-              <a:lnSpc>
-                <a:spcPct val="130000"/>
-              </a:lnSpc>
-              <a:spcAft>
-                <a:spcPts val="800"/>
-              </a:spcAft>
-              <a:buSzPct val="100000"/>
-              <a:buChar char="•"/>
-            </a:pPr>
-            <a:r>
-              <a:rPr lang="en-US" sz="1250" dirty="0">
-                <a:solidFill>
-                  <a:srgbClr val="1F1F1F"/>
-                </a:solidFill>
-                <a:latin typeface="Yu Gothic" pitchFamily="34" charset="0"/>
-                <a:ea typeface="Yu Gothic" pitchFamily="34" charset="-122"/>
-                <a:cs typeface="Yu Gothic" pitchFamily="34" charset="-120"/>
-              </a:rPr>
-              <a:t>元NHKの番組制作者を含む、編集・取材の視点</a:t>
-            </a:r>
-            <a:endParaRPr lang="en-US" sz="1250" dirty="0"/>
-          </a:p>
-          <a:p>
-            <a:pPr marL="342900" indent="-342900">
-              <a:lnSpc>
-                <a:spcPct val="130000"/>
-              </a:lnSpc>
-              <a:spcAft>
-                <a:spcPts val="800"/>
-              </a:spcAft>
-              <a:buSzPct val="100000"/>
-              <a:buChar char="•"/>
-            </a:pPr>
-            <a:r>
-              <a:rPr lang="en-US" sz="1250" dirty="0">
-                <a:solidFill>
-                  <a:srgbClr val="1F1F1F"/>
-                </a:solidFill>
-                <a:latin typeface="Yu Gothic" pitchFamily="34" charset="0"/>
-                <a:ea typeface="Yu Gothic" pitchFamily="34" charset="-122"/>
-                <a:cs typeface="Yu Gothic" pitchFamily="34" charset="-120"/>
-              </a:rPr>
-              <a:t>テレビ・新聞・Webを横断した企画づくり</a:t>
-            </a:r>
-            <a:endParaRPr lang="en-US" sz="1250" dirty="0"/>
+              <a:rPr lang="en-US" sz="1100" dirty="0">
+                <a:solidFill>
+                  <a:srgbClr val="6B6B6B"/>
+                </a:solidFill>
+                <a:latin typeface="Yu Gothic" pitchFamily="34" charset="0"/>
+                <a:ea typeface="Yu Gothic" pitchFamily="34" charset="-122"/>
+                <a:cs typeface="Yu Gothic" pitchFamily="34" charset="-120"/>
+              </a:rPr>
+              <a:t>法律の内容の正確さは御センターに最終確認いただき、私たちは「正しく伝わる言葉と順番」に責任を持ちます。</a:t>
+            </a:r>
+            <a:endParaRPr lang="en-US" sz="1100" dirty="0"/>
           </a:p>
         </p:txBody>
       </p:sp>
       <p:sp>
         <p:nvSpPr>
           <p:cNvPr id="21" name="Text 19"/>
-          <p:cNvSpPr txBox="1"/>
-          <p:nvPr/>
-        </p:nvSpPr>
-        <p:spPr>
-          <a:xfrm>
-            <a:off x="7132320" y="4937760"/>
-            <a:ext cx="4007815" cy="822960"/>
-          </a:xfrm>
-          <a:prstGeom prst="rect">
-            <a:avLst/>
-          </a:prstGeom>
-          <a:noFill/>
-          <a:ln/>
-        </p:spPr>
-        <p:txBody>
-          <a:bodyPr wrap="square" lIns="0" tIns="0" rIns="0" bIns="0" rtlCol="0" anchor="t"/>
-          <a:lstStyle/>
-          <a:p>
-            <a:pPr indent="0" marL="0">
-              <a:lnSpc>
-                <a:spcPct val="135000"/>
-              </a:lnSpc>
-              <a:buNone/>
-            </a:pPr>
-            <a:r>
-              <a:rPr lang="en-US" sz="1100" dirty="0">
-                <a:solidFill>
-                  <a:srgbClr val="6B6B6B"/>
-                </a:solidFill>
-                <a:latin typeface="Yu Gothic" pitchFamily="34" charset="0"/>
-                <a:ea typeface="Yu Gothic" pitchFamily="34" charset="-122"/>
-                <a:cs typeface="Yu Gothic" pitchFamily="34" charset="-120"/>
-              </a:rPr>
-              <a:t>法律の内容の正確さは御センターに最終確認いただき、私たちは「正しく伝わる言葉と順番」に責任を持ちます。</a:t>
-            </a:r>
-            <a:endParaRPr lang="en-US" sz="1100" dirty="0"/>
-          </a:p>
-        </p:txBody>
-      </p:sp>
-      <p:sp>
-        <p:nvSpPr>
-          <p:cNvPr id="22" name="Text 20"/>
           <p:cNvSpPr txBox="1"/>
           <p:nvPr/>
         </p:nvSpPr>

</xml_diff>